<commit_message>
slide monev: berkas final PowerPoint dan PDF
</commit_message>
<xml_diff>
--- a/slide-monev.pptx
+++ b/slide-monev.pptx
@@ -939,7 +939,7 @@
         <c:numFmt formatCode="General" sourceLinked="1"/>
         <c:majorTickMark val="none"/>
         <c:minorTickMark val="none"/>
-        <c:tickLblPos val="nextTo"/>
+        <c:tickLblPos val="low"/>
         <c:spPr>
           <a:ln>
             <a:solidFill>
@@ -1005,7 +1005,7 @@
         <c:numFmt formatCode="General" sourceLinked="1"/>
         <c:majorTickMark val="none"/>
         <c:minorTickMark val="none"/>
-        <c:tickLblPos val="nextTo"/>
+        <c:tickLblPos val="low"/>
         <c:spPr>
           <a:ln>
             <a:solidFill>
@@ -4636,8 +4636,8 @@
         </p:blipFill>
         <p:spPr>
           <a:xfrm>
-            <a:off x="658368" y="1773936"/>
-            <a:ext cx="1907014" cy="1335024"/>
+            <a:off x="1237601" y="1796795"/>
+            <a:ext cx="2088567" cy="1289304"/>
           </a:xfrm>
           <a:prstGeom prst="rect">
             <a:avLst/>
@@ -4687,8 +4687,8 @@
         </p:nvSpPr>
         <p:spPr>
           <a:xfrm>
-            <a:off x="566928" y="3584448"/>
-            <a:ext cx="3429914" cy="548640"/>
+            <a:off x="566928" y="3566160"/>
+            <a:ext cx="3429914" cy="512064"/>
           </a:xfrm>
           <a:prstGeom prst="rect">
             <a:avLst/>
@@ -4726,8 +4726,8 @@
         </p:nvSpPr>
         <p:spPr>
           <a:xfrm>
-            <a:off x="566928" y="4261104"/>
-            <a:ext cx="3429914" cy="1371600"/>
+            <a:off x="566928" y="4169663"/>
+            <a:ext cx="3429914" cy="1463040"/>
           </a:xfrm>
           <a:prstGeom prst="rect">
             <a:avLst/>
@@ -4819,8 +4819,8 @@
         </p:blipFill>
         <p:spPr>
           <a:xfrm>
-            <a:off x="4472330" y="1773936"/>
-            <a:ext cx="3601683" cy="1335024"/>
+            <a:off x="4552550" y="1879504"/>
+            <a:ext cx="3086593" cy="1123887"/>
           </a:xfrm>
           <a:prstGeom prst="rect">
             <a:avLst/>
@@ -4870,8 +4870,8 @@
         </p:nvSpPr>
         <p:spPr>
           <a:xfrm>
-            <a:off x="4380890" y="3584448"/>
-            <a:ext cx="3429914" cy="548640"/>
+            <a:off x="4380890" y="3566160"/>
+            <a:ext cx="3429914" cy="512064"/>
           </a:xfrm>
           <a:prstGeom prst="rect">
             <a:avLst/>
@@ -4909,8 +4909,8 @@
         </p:nvSpPr>
         <p:spPr>
           <a:xfrm>
-            <a:off x="4380890" y="4261104"/>
-            <a:ext cx="3429914" cy="1371600"/>
+            <a:off x="4380890" y="4169663"/>
+            <a:ext cx="3429914" cy="1463040"/>
           </a:xfrm>
           <a:prstGeom prst="rect">
             <a:avLst/>
@@ -5002,8 +5002,8 @@
         </p:blipFill>
         <p:spPr>
           <a:xfrm>
-            <a:off x="8286292" y="1773936"/>
-            <a:ext cx="1715969" cy="1335024"/>
+            <a:off x="8976800" y="1796795"/>
+            <a:ext cx="1866018" cy="1289304"/>
           </a:xfrm>
           <a:prstGeom prst="rect">
             <a:avLst/>
@@ -5053,8 +5053,8 @@
         </p:nvSpPr>
         <p:spPr>
           <a:xfrm>
-            <a:off x="8194852" y="3584448"/>
-            <a:ext cx="3429914" cy="548640"/>
+            <a:off x="8194852" y="3566160"/>
+            <a:ext cx="3429914" cy="512064"/>
           </a:xfrm>
           <a:prstGeom prst="rect">
             <a:avLst/>
@@ -5092,8 +5092,8 @@
         </p:nvSpPr>
         <p:spPr>
           <a:xfrm>
-            <a:off x="8194852" y="4261104"/>
-            <a:ext cx="3429914" cy="1371600"/>
+            <a:off x="8194852" y="4169663"/>
+            <a:ext cx="3429914" cy="1463040"/>
           </a:xfrm>
           <a:prstGeom prst="rect">
             <a:avLst/>
@@ -5605,8 +5605,8 @@
         </p:blipFill>
         <p:spPr>
           <a:xfrm>
-            <a:off x="676656" y="2199132"/>
-            <a:ext cx="1371600" cy="745089"/>
+            <a:off x="691286" y="2234452"/>
+            <a:ext cx="1580083" cy="779751"/>
           </a:xfrm>
           <a:prstGeom prst="rect">
             <a:avLst/>
@@ -5936,8 +5936,8 @@
         </p:blipFill>
         <p:spPr>
           <a:xfrm>
-            <a:off x="6315303" y="2199132"/>
-            <a:ext cx="1371600" cy="725432"/>
+            <a:off x="6329934" y="2240974"/>
+            <a:ext cx="1580083" cy="766707"/>
           </a:xfrm>
           <a:prstGeom prst="rect">
             <a:avLst/>
@@ -6372,8 +6372,8 @@
         </p:blipFill>
         <p:spPr>
           <a:xfrm>
-            <a:off x="1094193" y="4023359"/>
-            <a:ext cx="1572768" cy="598553"/>
+            <a:off x="724812" y="4097363"/>
+            <a:ext cx="2311530" cy="729817"/>
           </a:xfrm>
           <a:prstGeom prst="rect">
             <a:avLst/>
@@ -6703,8 +6703,8 @@
         </p:blipFill>
         <p:spPr>
           <a:xfrm>
-            <a:off x="3959237" y="4023359"/>
-            <a:ext cx="1463040" cy="788184"/>
+            <a:off x="3801503" y="4023360"/>
+            <a:ext cx="1778507" cy="877823"/>
           </a:xfrm>
           <a:prstGeom prst="rect">
             <a:avLst/>
@@ -7034,8 +7034,8 @@
         </p:blipFill>
         <p:spPr>
           <a:xfrm>
-            <a:off x="6769417" y="4023359"/>
-            <a:ext cx="1463040" cy="680092"/>
+            <a:off x="6420757" y="4023360"/>
+            <a:ext cx="2160359" cy="877823"/>
           </a:xfrm>
           <a:prstGeom prst="rect">
             <a:avLst/>
@@ -7365,8 +7365,8 @@
         </p:blipFill>
         <p:spPr>
           <a:xfrm>
-            <a:off x="9762477" y="4023359"/>
-            <a:ext cx="1097280" cy="879393"/>
+            <a:off x="9745942" y="4023359"/>
+            <a:ext cx="1130348" cy="877824"/>
           </a:xfrm>
           <a:prstGeom prst="rect">
             <a:avLst/>
@@ -9280,8 +9280,8 @@
         </p:blipFill>
         <p:spPr>
           <a:xfrm>
-            <a:off x="676656" y="1755648"/>
-            <a:ext cx="5080863" cy="2869259"/>
+            <a:off x="1031150" y="1737360"/>
+            <a:ext cx="4371873" cy="2468880"/>
           </a:xfrm>
           <a:prstGeom prst="rect">
             <a:avLst/>
@@ -9398,8 +9398,8 @@
         </p:blipFill>
         <p:spPr>
           <a:xfrm>
-            <a:off x="6434175" y="1755648"/>
-            <a:ext cx="5080863" cy="3210683"/>
+            <a:off x="7021122" y="1737360"/>
+            <a:ext cx="3906969" cy="2468880"/>
           </a:xfrm>
           <a:prstGeom prst="rect">
             <a:avLst/>

</xml_diff>